<commit_message>
Team standing deck: drop the one-survey line for Jana
Co-Authored-By: Claude Opus 5.5 <noreply@anthropic.com>
Claude-Session: https://claude.ai/code/session_0155HmpRbXu6PvYwYnChFpPm
</commit_message>
<xml_diff>
--- a/coaching-intelligence-pro/Team_Standing_Omar_Mansour.pptx
+++ b/coaching-intelligence-pro/Team_Standing_Omar_Mansour.pptx
@@ -111,27 +111,27 @@
   <p:extLst>
     <p:ext uri="{521415D9-36F7-43E2-AB2F-B90AF26B5E84}">
       <p14:sectionLst xmlns:p14="http://schemas.microsoft.com/office/powerpoint/2010/main">
-        <p14:section name="Open" id="{82292a20-6f76-ea76-f676-2facf2a78d49}">
+        <p14:section name="Open" id="{d2283334-512e-543b-fab2-1da780bb104b}">
           <p14:sldIdLst>
             <p14:sldId id="256"/>
           </p14:sldIdLst>
         </p14:section>
-        <p14:section name="Where the team stands" id="{86be2af7-4237-6d83-64d2-f812b63437cc}">
+        <p14:section name="Where the team stands" id="{231599e5-8bf7-ecca-da21-4bd99bd979fe}">
           <p14:sldIdLst>
             <p14:sldId id="257"/>
           </p14:sldIdLst>
         </p14:section>
-        <p14:section name="The offenders" id="{acfc8806-f48b-11c9-6f13-46e557e52a00}">
+        <p14:section name="The offenders" id="{8369a339-98e9-0cee-5f49-3119000b73f8}">
           <p14:sldIdLst>
             <p14:sldId id="258"/>
           </p14:sldIdLst>
         </p14:section>
-        <p14:section name="How I coach" id="{d88cc189-ca83-e6e7-c083-af54cf8e3d83}">
+        <p14:section name="How I coach" id="{efe86785-5697-b859-c307-a78b5d5a4bab}">
           <p14:sldIdLst>
             <p14:sldId id="259"/>
           </p14:sldIdLst>
         </p14:section>
-        <p14:section name="Next 30 days" id="{e0a8fec0-705b-ead3-104e-953b2e9dba7e}">
+        <p14:section name="Next 30 days" id="{0f23bdb2-59d3-4e60-6fcd-93f2bb253527}">
           <p14:sldIdLst>
             <p14:sldId id="260"/>
           </p14:sldIdLst>
@@ -1223,7 +1223,7 @@
           <a:p>
             <a:r>
               <a:rPr lang="en-US" dirty="0"/>
-              <a:t>These are the five I am working on first. Ammar is the clearest case. He resolves and he sells, rank 54 of 220, but he is at minus 37.5 on 16 surveys. I already know his gap is how he handles the call, setting expectations and the close, not knowledge. So he gets one focus, clear next steps and timeframes before he closes, and I sit with him on 2 calls a week. Jana is on only 7 surveys, so one survey moves her about 14 points. With her it is resolution first and the right ITG from start to finish. Mohamed Mahmoud resolves fine, so the work is ownership and assurance, then the mobile offer after the fix. Ahmed Elbanna has the lowest aiCR on the team, so it is discovery and confirming the fix before he closes. Rashwan is the opposite case. He is at 100 on tNPS but has no XM lines yet, so we work on earning the offer once the fix is done. Ahmed Ali, Abdelwahab and Omar Kamel are at zero, and they are next.</a:t>
+              <a:t>These are the five I am working on first. Ammar is the clearest case. He resolves and he sells, rank 54 of 220, but he is at minus 37.5 on 16 surveys. I already know his gap is how he handles the call, setting expectations and the close, not knowledge. So he gets one focus, clear next steps and timeframes before he closes, and I sit with him on 2 calls a week. Jana is at minus 42.9 with aiCR at 58.3. With her it is resolution first and the right ITG from start to finish. Mohamed Mahmoud resolves fine, so the work is ownership and assurance, then the mobile offer after the fix. Ahmed Elbanna has the lowest aiCR on the team, so it is discovery and confirming the fix before he closes. Rashwan is the opposite case. He is at 100 on tNPS but has no XM lines yet, so we work on earning the offer once the fix is done. Ahmed Ali, Abdelwahab and Omar Kamel are at zero, and they are next.</a:t>
             </a:r>
             <a:endParaRPr lang="en-US" dirty="0"/>
           </a:p>
@@ -4977,7 +4977,7 @@
                           <a:ea typeface="Calibri" pitchFamily="34" charset="-122"/>
                           <a:cs typeface="Calibri" pitchFamily="34" charset="-120"/>
                         </a:rPr>
-                        <a:t>aiCR 58.3%, GSR 4.2%. One survey moves her about 14 points</a:t>
+                        <a:t>aiCR 58.3%, GSR 4.2%</a:t>
                       </a:r>
                       <a:endParaRPr lang="en-US" sz="1200" dirty="0">
                         <a:latin typeface="Calibri" charset="0"/>

</xml_diff>